<commit_message>
Update user manual and quick guide for optional attendee comment
</commit_message>
<xml_diff>
--- a/docs/MBT Sales Operations - Quick Guide (SE-BD).pptx
+++ b/docs/MBT Sales Operations - Quick Guide (SE-BD).pptx
@@ -7296,7 +7296,7 @@
                 <a:ea typeface="Calibri" pitchFamily="34" charset="-122"/>
                 <a:cs typeface="Calibri" pitchFamily="34" charset="-120"/>
               </a:rPr>
-              <a:t>The attendee sees a clean, read-only summary of the visit and taps "Confirm Meeting Happened."</a:t>
+              <a:t>The attendee sees a clean, read-only summary of the visit and an optional comment box — they can add a note or just leave it blank.</a:t>
             </a:r>
             <a:endParaRPr lang="en-US" sz="1500" dirty="0"/>
           </a:p>
@@ -7317,7 +7317,7 @@
                 <a:ea typeface="Calibri" pitchFamily="34" charset="-122"/>
                 <a:cs typeface="Calibri" pitchFamily="34" charset="-120"/>
               </a:rPr>
-              <a:t>The moment they confirm, your FCR is automatically submitted for approval — nothing more to do.</a:t>
+              <a:t>The moment they tap "Confirm Meeting Happened," your FCR is automatically submitted for approval — nothing more to do.</a:t>
             </a:r>
             <a:endParaRPr lang="en-US" sz="1500" dirty="0"/>
           </a:p>
@@ -7359,7 +7359,7 @@
                 <a:ea typeface="Calibri" pitchFamily="34" charset="-122"/>
                 <a:cs typeface="Calibri" pitchFamily="34" charset="-120"/>
               </a:rPr>
-              <a:t>If something looks off in the minutes, the attendee's supervisor contact is included in the email (see last slide).</a:t>
+              <a:t>If they left a comment, it shows up on your FCR's Account Acknowledgment card — no separate email or message to check.</a:t>
             </a:r>
             <a:endParaRPr lang="en-US" sz="1500" dirty="0"/>
           </a:p>
@@ -7394,7 +7394,7 @@
       </p:sp>
       <p:pic>
         <p:nvPicPr>
-          <p:cNvPr id="6" name="Image 0" descr="/sessions/lucid-bold-fermi/mnt/outputs/screenshot-1785056849644-a11806ce.jpg">    </p:cNvPr>
+          <p:cNvPr id="6" name="Image 0" descr="/sessions/lucid-bold-fermi/mnt/outputs/screenshot-1785059060225-26a10fdd.jpg">    </p:cNvPr>
           <p:cNvPicPr>
             <a:picLocks noChangeAspect="1"/>
           </p:cNvPicPr>

</xml_diff>

<commit_message>
Update manual and quick guide for BD Spec-in import routing
</commit_message>
<xml_diff>
--- a/docs/MBT Sales Operations - Quick Guide (SE-BD).pptx
+++ b/docs/MBT Sales Operations - Quick Guide (SE-BD).pptx
@@ -6669,6 +6669,27 @@
                 <a:ea typeface="Calibri" pitchFamily="34" charset="-122"/>
                 <a:cs typeface="Calibri" pitchFamily="34" charset="-120"/>
               </a:rPr>
+              <a:t>Linked MBT Project Pipeline projects can be imported straight into Project Opportunities — Bidding-stage projects go to Qualified / Identified; on a BD FCR, Spec-in-flagged projects go to SPEC-IN.</a:t>
+            </a:r>
+            <a:endParaRPr lang="en-US" sz="1500" dirty="0"/>
+          </a:p>
+          <a:p>
+            <a:pPr marL="342900" indent="-342900">
+              <a:spcAft>
+                <a:spcPts val="1400"/>
+              </a:spcAft>
+              <a:buSzPct val="100000"/>
+              <a:buChar char="✦"/>
+            </a:pPr>
+            <a:r>
+              <a:rPr lang="en-US" sz="1500" dirty="0">
+                <a:solidFill>
+                  <a:srgbClr val="222530"/>
+                </a:solidFill>
+                <a:latin typeface="Calibri" pitchFamily="34" charset="0"/>
+                <a:ea typeface="Calibri" pitchFamily="34" charset="-122"/>
+                <a:cs typeface="Calibri" pitchFamily="34" charset="-120"/>
+              </a:rPr>
               <a:t>Every field you enter here becomes the Minutes of the Meeting the attendee reviews next.</a:t>
             </a:r>
             <a:endParaRPr lang="en-US" sz="1500" dirty="0"/>

</xml_diff>